<commit_message>
chore: change template Row 0 header from Summary to Overview
</commit_message>
<xml_diff>
--- a/skills/aws-whats-new-pptx/assets/whats_new_template.pptx
+++ b/skills/aws-whats-new-pptx/assets/whats_new_template.pptx
@@ -919,7 +919,7 @@
             <a:fld id="{06736434-7E81-994B-854B-1BF33F160A0D}" type="datetime1">
               <a:rPr lang="en-US" smtClean="0"/>
               <a:pPr/>
-              <a:t>3/5/26</a:t>
+              <a:t>3/6/26</a:t>
             </a:fld>
             <a:endParaRPr lang="en-US" dirty="0"/>
           </a:p>
@@ -2240,7 +2240,7 @@
             <a:fld id="{3B1EF3D5-2436-9240-B6D0-2048A71FFF33}" type="datetime1">
               <a:rPr lang="en-US" smtClean="0"/>
               <a:pPr/>
-              <a:t>3/5/26</a:t>
+              <a:t>3/6/26</a:t>
             </a:fld>
             <a:endParaRPr lang="en-US" dirty="0"/>
           </a:p>
@@ -2857,7 +2857,7 @@
         <p:spPr>
           <a:xfrm>
             <a:off x="672969" y="2967335"/>
-            <a:ext cx="6460999" cy="923330"/>
+            <a:ext cx="9528306" cy="923330"/>
           </a:xfrm>
         </p:spPr>
         <p:txBody>
@@ -2930,7 +2930,7 @@
           <p:nvPr>
             <p:extLst>
               <p:ext uri="{D42A27DB-BD31-4B8C-83A1-F6EECF244321}">
-                <p14:modId xmlns:p14="http://schemas.microsoft.com/office/powerpoint/2010/main" val="2996797965"/>
+                <p14:modId xmlns:p14="http://schemas.microsoft.com/office/powerpoint/2010/main" val="3318361835"/>
               </p:ext>
             </p:extLst>
           </p:nvPr>
@@ -2961,13 +2961,18 @@
                     <a:lstStyle/>
                     <a:p>
                       <a:r>
-                        <a:rPr lang="en-US" sz="1400" dirty="0">
+                        <a:rPr lang="ko-KR" altLang="en-US" sz="1400">
                           <a:latin typeface="Amazon Ember" panose="020B0603020204020204" pitchFamily="34" charset="0"/>
                           <a:ea typeface="Amazon Ember" panose="020B0603020204020204" pitchFamily="34" charset="0"/>
                           <a:cs typeface="Amazon Ember" panose="020B0603020204020204" pitchFamily="34" charset="0"/>
                         </a:rPr>
-                        <a:t>Summary</a:t>
+                        <a:t>개요</a:t>
                       </a:r>
+                      <a:endParaRPr lang="en-US" sz="1400" dirty="0">
+                        <a:latin typeface="Amazon Ember" panose="020B0603020204020204" pitchFamily="34" charset="0"/>
+                        <a:ea typeface="Amazon Ember" panose="020B0603020204020204" pitchFamily="34" charset="0"/>
+                        <a:cs typeface="Amazon Ember" panose="020B0603020204020204" pitchFamily="34" charset="0"/>
+                      </a:endParaRPr>
                     </a:p>
                   </a:txBody>
                   <a:tcPr marL="121920" marR="121920" marT="60960" marB="60960">

</xml_diff>

<commit_message>
feat: inline hyperlinks for related links section
- Change summary-agent.md related links format from bullet list with
  bare URLs to inline [text](url) | [text](url) format
- Reduces related links from 3+ lines to 2 lines (header + inline links)
- Update template asset
</commit_message>
<xml_diff>
--- a/skills/aws-whats-new-pptx/assets/whats_new_template.pptx
+++ b/skills/aws-whats-new-pptx/assets/whats_new_template.pptx
@@ -2930,7 +2930,7 @@
           <p:nvPr>
             <p:extLst>
               <p:ext uri="{D42A27DB-BD31-4B8C-83A1-F6EECF244321}">
-                <p14:modId xmlns:p14="http://schemas.microsoft.com/office/powerpoint/2010/main" val="3318361835"/>
+                <p14:modId xmlns:p14="http://schemas.microsoft.com/office/powerpoint/2010/main" val="2841972593"/>
               </p:ext>
             </p:extLst>
           </p:nvPr>
@@ -2961,7 +2961,7 @@
                     <a:lstStyle/>
                     <a:p>
                       <a:r>
-                        <a:rPr lang="ko-KR" altLang="en-US" sz="1400">
+                        <a:rPr lang="ko-KR" altLang="en-US" sz="1400" dirty="0">
                           <a:latin typeface="Amazon Ember" panose="020B0603020204020204" pitchFamily="34" charset="0"/>
                           <a:ea typeface="Amazon Ember" panose="020B0603020204020204" pitchFamily="34" charset="0"/>
                           <a:cs typeface="Amazon Ember" panose="020B0603020204020204" pitchFamily="34" charset="0"/>
@@ -2975,7 +2975,7 @@
                       </a:endParaRPr>
                     </a:p>
                   </a:txBody>
-                  <a:tcPr marL="121920" marR="121920" marT="60960" marB="60960">
+                  <a:tcPr marL="121920" marR="121920" marT="60960" marB="60960" anchor="ctr">
                     <a:solidFill>
                       <a:schemeClr val="bg1"/>
                     </a:solidFill>
@@ -3044,6 +3044,43 @@
               </a:rPr>
               <a:t>{Title}</a:t>
             </a:r>
+          </a:p>
+        </p:txBody>
+      </p:sp>
+      <p:sp>
+        <p:nvSpPr>
+          <p:cNvPr id="2" name="TextBox 1">
+            <a:extLst>
+              <a:ext uri="{FF2B5EF4-FFF2-40B4-BE49-F238E27FC236}">
+                <a16:creationId xmlns:a16="http://schemas.microsoft.com/office/drawing/2014/main" id="{66E4276F-4D61-4CD7-8C17-01D11F9F5F88}"/>
+              </a:ext>
+            </a:extLst>
+          </p:cNvPr>
+          <p:cNvSpPr txBox="1"/>
+          <p:nvPr/>
+        </p:nvSpPr>
+        <p:spPr>
+          <a:xfrm>
+            <a:off x="10244663" y="914400"/>
+            <a:ext cx="1683985" cy="307777"/>
+          </a:xfrm>
+          <a:prstGeom prst="rect">
+            <a:avLst/>
+          </a:prstGeom>
+          <a:noFill/>
+        </p:spPr>
+        <p:txBody>
+          <a:bodyPr wrap="square" lIns="0" rIns="0" rtlCol="0">
+            <a:spAutoFit/>
+          </a:bodyPr>
+          <a:lstStyle/>
+          <a:p>
+            <a:pPr algn="r"/>
+            <a:r>
+              <a:rPr lang="en-US" sz="1400" dirty="0"/>
+              <a:t>{date}</a:t>
+            </a:r>
+            <a:endParaRPr lang="en-KR" sz="1400" dirty="0" err="1"/>
           </a:p>
         </p:txBody>
       </p:sp>

</xml_diff>

<commit_message>
feat: add translation mode for full Korean translation of announcements
- Add references/translation-agent.md with translation rules
  (literal translation, technical term annotation, preserve structure)
- Add mode branching in SKILL.md Step 2 (summary vs translation)
- Update SKILL.md description with translation trigger keywords
- Add translation-agent.md to reference file table
</commit_message>
<xml_diff>
--- a/skills/aws-whats-new-pptx/assets/whats_new_template.pptx
+++ b/skills/aws-whats-new-pptx/assets/whats_new_template.pptx
@@ -636,6 +636,12 @@
             <a:pPr>
               <a:buNone/>
             </a:pPr>
+            <a:r>
+              <a:rPr lang="en-US" altLang="ko-KR" b="0">
+                <a:effectLst/>
+              </a:rPr>
+              <a:t>{script}</a:t>
+            </a:r>
             <a:endParaRPr lang="en-US" altLang="ko-KR" b="0" dirty="0">
               <a:effectLst/>
             </a:endParaRPr>

</xml_diff>